<commit_message>
course(validation): author hand-edits to the Validation deck
Co-Authored-By: Claude Opus 4.8 <noreply@anthropic.com>
</commit_message>
<xml_diff>
--- a/course/lectures/act-1-foundations/08-validation/1-8-Validation.pptx
+++ b/course/lectures/act-1-foundations/08-validation/1-8-Validation.pptx
@@ -5,46 +5,46 @@
     <p:sldMasterId id="2147483708" r:id="rId1"/>
   </p:sldMasterIdLst>
   <p:notesMasterIdLst>
-    <p:notesMasterId r:id="rId31"/>
+    <p:notesMasterId r:id="rId39"/>
   </p:notesMasterIdLst>
   <p:sldIdLst>
-    <p:sldId id="257" r:id="rId101"/>
-    <p:sldId id="258" r:id="rId102"/>
-    <p:sldId id="259" r:id="rId103"/>
-    <p:sldId id="260" r:id="rId104"/>
-    <p:sldId id="261" r:id="rId105"/>
-    <p:sldId id="262" r:id="rId106"/>
-    <p:sldId id="263" r:id="rId107"/>
-    <p:sldId id="264" r:id="rId108"/>
-    <p:sldId id="265" r:id="rId109"/>
-    <p:sldId id="266" r:id="rId110"/>
-    <p:sldId id="267" r:id="rId111"/>
-    <p:sldId id="268" r:id="rId112"/>
-    <p:sldId id="269" r:id="rId113"/>
-    <p:sldId id="270" r:id="rId114"/>
-    <p:sldId id="271" r:id="rId115"/>
-    <p:sldId id="272" r:id="rId116"/>
-    <p:sldId id="273" r:id="rId117"/>
-    <p:sldId id="274" r:id="rId118"/>
-    <p:sldId id="275" r:id="rId119"/>
-    <p:sldId id="276" r:id="rId120"/>
-    <p:sldId id="277" r:id="rId121"/>
-    <p:sldId id="278" r:id="rId122"/>
-    <p:sldId id="279" r:id="rId123"/>
-    <p:sldId id="280" r:id="rId124"/>
-    <p:sldId id="281" r:id="rId125"/>
-    <p:sldId id="282" r:id="rId126"/>
-    <p:sldId id="283" r:id="rId127"/>
-    <p:sldId id="284" r:id="rId128"/>
-    <p:sldId id="285" r:id="rId129"/>
-    <p:sldId id="286" r:id="rId130"/>
-    <p:sldId id="287" r:id="rId131"/>
-    <p:sldId id="288" r:id="rId132"/>
-    <p:sldId id="289" r:id="rId133"/>
-    <p:sldId id="290" r:id="rId134"/>
-    <p:sldId id="291" r:id="rId135"/>
-    <p:sldId id="292" r:id="rId136"/>
-    <p:sldId id="293" r:id="rId137"/>
+    <p:sldId id="257" r:id="rId2"/>
+    <p:sldId id="258" r:id="rId3"/>
+    <p:sldId id="259" r:id="rId4"/>
+    <p:sldId id="260" r:id="rId5"/>
+    <p:sldId id="261" r:id="rId6"/>
+    <p:sldId id="262" r:id="rId7"/>
+    <p:sldId id="263" r:id="rId8"/>
+    <p:sldId id="264" r:id="rId9"/>
+    <p:sldId id="265" r:id="rId10"/>
+    <p:sldId id="266" r:id="rId11"/>
+    <p:sldId id="267" r:id="rId12"/>
+    <p:sldId id="268" r:id="rId13"/>
+    <p:sldId id="269" r:id="rId14"/>
+    <p:sldId id="270" r:id="rId15"/>
+    <p:sldId id="271" r:id="rId16"/>
+    <p:sldId id="272" r:id="rId17"/>
+    <p:sldId id="273" r:id="rId18"/>
+    <p:sldId id="274" r:id="rId19"/>
+    <p:sldId id="275" r:id="rId20"/>
+    <p:sldId id="276" r:id="rId21"/>
+    <p:sldId id="277" r:id="rId22"/>
+    <p:sldId id="278" r:id="rId23"/>
+    <p:sldId id="279" r:id="rId24"/>
+    <p:sldId id="280" r:id="rId25"/>
+    <p:sldId id="281" r:id="rId26"/>
+    <p:sldId id="282" r:id="rId27"/>
+    <p:sldId id="283" r:id="rId28"/>
+    <p:sldId id="284" r:id="rId29"/>
+    <p:sldId id="285" r:id="rId30"/>
+    <p:sldId id="286" r:id="rId31"/>
+    <p:sldId id="287" r:id="rId32"/>
+    <p:sldId id="288" r:id="rId33"/>
+    <p:sldId id="289" r:id="rId34"/>
+    <p:sldId id="290" r:id="rId35"/>
+    <p:sldId id="291" r:id="rId36"/>
+    <p:sldId id="292" r:id="rId37"/>
+    <p:sldId id="293" r:id="rId38"/>
   </p:sldIdLst>
   <p:sldSz cx="9144000" cy="6858000" type="screen4x3"/>
   <p:notesSz cx="6858000" cy="9144000"/>
@@ -235,7 +235,7 @@
           </a:lstStyle>
           <a:p>
             <a:fld id="{27E8B4C4-0720-F64E-9EEE-9472CF165DC6}" type="datetimeFigureOut">
-              <a:t>9/11/26</a:t>
+              <a:t>9/18/26</a:t>
             </a:fld>
             <a:endParaRPr lang="en-US"/>
           </a:p>
@@ -3066,7 +3066,7 @@
             </a:r>
             <a:r>
               <a:rPr lang="en-US" b="1" u="none" dirty="0"/>
-              <a:t xml:space="preserve">		Details</a:t>
+              <a:t>		Details</a:t>
             </a:r>
           </a:p>
           <a:p>
@@ -3243,7 +3243,7 @@
             </a:r>
             <a:r>
               <a:rPr lang="en-US" b="1" u="none" dirty="0"/>
-              <a:t xml:space="preserve">		Details</a:t>
+              <a:t>		Details</a:t>
             </a:r>
           </a:p>
           <a:p>
@@ -4536,7 +4536,7 @@
           <a:p>
             <a:fld id="{B7EB45DA-9A0D-DC49-8E02-F30A5DDC21C3}" type="slidenum">
               <a:rPr lang="en-US" smtClean="0"/>
-              <a:t>1</a:t>
+              <a:t>10</a:t>
             </a:fld>
             <a:endParaRPr lang="en-US"/>
           </a:p>
@@ -4921,7 +4921,7 @@
           <a:p>
             <a:fld id="{B7EB45DA-9A0D-DC49-8E02-F30A5DDC21C3}" type="slidenum">
               <a:rPr lang="en-US" smtClean="0"/>
-              <a:t>1</a:t>
+              <a:t>11</a:t>
             </a:fld>
             <a:endParaRPr lang="en-US"/>
           </a:p>
@@ -4962,6 +4962,13 @@
             </a:solidFill>
           </a:ln>
         </p:spPr>
+        <p:txBody>
+          <a:bodyPr/>
+          <a:lstStyle/>
+          <a:p>
+            <a:endParaRPr lang="en-US"/>
+          </a:p>
+        </p:txBody>
       </p:sp>
       <p:sp>
         <p:nvSpPr>
@@ -4998,6 +5005,13 @@
             </a:solidFill>
           </a:ln>
         </p:spPr>
+        <p:txBody>
+          <a:bodyPr/>
+          <a:lstStyle/>
+          <a:p>
+            <a:endParaRPr lang="en-US"/>
+          </a:p>
+        </p:txBody>
       </p:sp>
       <p:sp>
         <p:nvSpPr>
@@ -5402,7 +5416,7 @@
       </p:sp>
       <p:sp>
         <p:nvSpPr>
-          <p:cNvPr id="113" name="FooterBand"/>
+          <p:cNvPr id="4" name="FooterBand"/>
           <p:cNvSpPr/>
           <p:nvPr/>
         </p:nvSpPr>
@@ -5453,19 +5467,19 @@
               <p:cTn id="2" dur="indefinite" nodeType="mainSeq">
                 <p:childTnLst>
                   <p:par>
-                    <p:cTn id="9" fill="hold">
+                    <p:cTn id="3" fill="hold">
                       <p:stCondLst>
                         <p:cond delay="indefinite"/>
                       </p:stCondLst>
                       <p:childTnLst>
                         <p:par>
-                          <p:cTn id="5" fill="hold">
+                          <p:cTn id="4" fill="hold">
                             <p:stCondLst>
                               <p:cond delay="0"/>
                             </p:stCondLst>
                             <p:childTnLst>
                               <p:par>
-                                <p:cTn id="8" presetID="10" presetClass="entr" presetSubtype="0" fill="hold" grpId="0" nodeType="clickEffect">
+                                <p:cTn id="5" presetID="10" presetClass="entr" presetSubtype="0" fill="hold" grpId="0" nodeType="clickEffect">
                                   <p:stCondLst>
                                     <p:cond delay="0"/>
                                   </p:stCondLst>
@@ -5506,19 +5520,19 @@
                     </p:cTn>
                   </p:par>
                   <p:par>
-                    <p:cTn id="14" fill="hold">
+                    <p:cTn id="8" fill="hold">
                       <p:stCondLst>
                         <p:cond delay="indefinite"/>
                       </p:stCondLst>
                       <p:childTnLst>
                         <p:par>
-                          <p:cTn id="10" fill="hold">
+                          <p:cTn id="9" fill="hold">
                             <p:stCondLst>
                               <p:cond delay="0"/>
                             </p:stCondLst>
                             <p:childTnLst>
                               <p:par>
-                                <p:cTn id="13" presetID="10" presetClass="entr" presetSubtype="0" fill="hold" grpId="1" nodeType="clickEffect">
+                                <p:cTn id="10" presetID="10" presetClass="entr" presetSubtype="0" fill="hold" grpId="1" nodeType="clickEffect">
                                   <p:stCondLst>
                                     <p:cond delay="0"/>
                                   </p:stCondLst>
@@ -5559,19 +5573,19 @@
                     </p:cTn>
                   </p:par>
                   <p:par>
-                    <p:cTn id="19" fill="hold">
+                    <p:cTn id="13" fill="hold">
                       <p:stCondLst>
                         <p:cond delay="indefinite"/>
                       </p:stCondLst>
                       <p:childTnLst>
                         <p:par>
-                          <p:cTn id="15" fill="hold">
+                          <p:cTn id="14" fill="hold">
                             <p:stCondLst>
                               <p:cond delay="0"/>
                             </p:stCondLst>
                             <p:childTnLst>
                               <p:par>
-                                <p:cTn id="18" presetID="10" presetClass="entr" presetSubtype="0" fill="hold" grpId="2" nodeType="clickEffect">
+                                <p:cTn id="15" presetID="10" presetClass="entr" presetSubtype="0" fill="hold" grpId="2" nodeType="clickEffect">
                                   <p:stCondLst>
                                     <p:cond delay="0"/>
                                   </p:stCondLst>
@@ -5612,19 +5626,19 @@
                     </p:cTn>
                   </p:par>
                   <p:par>
-                    <p:cTn id="36" fill="hold">
+                    <p:cTn id="18" fill="hold">
                       <p:stCondLst>
                         <p:cond delay="indefinite"/>
                       </p:stCondLst>
                       <p:childTnLst>
                         <p:par>
-                          <p:cTn id="20" fill="hold">
+                          <p:cTn id="19" fill="hold">
                             <p:stCondLst>
                               <p:cond delay="0"/>
                             </p:stCondLst>
                             <p:childTnLst>
                               <p:par>
-                                <p:cTn id="23" presetID="10" presetClass="entr" presetSubtype="0" fill="hold" grpId="3" nodeType="clickEffect">
+                                <p:cTn id="20" presetID="10" presetClass="entr" presetSubtype="0" fill="hold" grpId="3" nodeType="clickEffect">
                                   <p:stCondLst>
                                     <p:cond delay="0"/>
                                   </p:stCondLst>
@@ -5662,13 +5676,13 @@
                           </p:cTn>
                         </p:par>
                         <p:par>
-                          <p:cTn id="24" fill="hold">
+                          <p:cTn id="23" fill="hold">
                             <p:stCondLst>
                               <p:cond delay="0"/>
                             </p:stCondLst>
                             <p:childTnLst>
                               <p:par>
-                                <p:cTn id="27" presetID="10" presetClass="entr" presetSubtype="0" fill="hold" grpId="4" nodeType="withEffect">
+                                <p:cTn id="24" presetID="10" presetClass="entr" presetSubtype="0" fill="hold" grpId="4" nodeType="withEffect">
                                   <p:stCondLst>
                                     <p:cond delay="0"/>
                                   </p:stCondLst>
@@ -5706,13 +5720,13 @@
                           </p:cTn>
                         </p:par>
                         <p:par>
-                          <p:cTn id="28" fill="hold">
+                          <p:cTn id="27" fill="hold">
                             <p:stCondLst>
                               <p:cond delay="0"/>
                             </p:stCondLst>
                             <p:childTnLst>
                               <p:par>
-                                <p:cTn id="31" presetID="10" presetClass="entr" presetSubtype="0" fill="hold" grpId="5" nodeType="withEffect">
+                                <p:cTn id="28" presetID="10" presetClass="entr" presetSubtype="0" fill="hold" grpId="5" nodeType="withEffect">
                                   <p:stCondLst>
                                     <p:cond delay="0"/>
                                   </p:stCondLst>
@@ -5750,13 +5764,13 @@
                           </p:cTn>
                         </p:par>
                         <p:par>
-                          <p:cTn id="32" fill="hold">
+                          <p:cTn id="31" fill="hold">
                             <p:stCondLst>
                               <p:cond delay="0"/>
                             </p:stCondLst>
                             <p:childTnLst>
                               <p:par>
-                                <p:cTn id="35" presetID="10" presetClass="entr" presetSubtype="0" fill="hold" grpId="6" nodeType="withEffect">
+                                <p:cTn id="32" presetID="10" presetClass="entr" presetSubtype="0" fill="hold" grpId="6" nodeType="withEffect">
                                   <p:stCondLst>
                                     <p:cond delay="0"/>
                                   </p:stCondLst>
@@ -5821,9 +5835,9 @@
       <p:bldP spid="110" grpId="0"/>
       <p:bldP spid="111" grpId="1"/>
       <p:bldP spid="112" grpId="2"/>
-      <p:bldP spid="113" grpId="3"/>
-      <p:bldP spid="114" grpId="4"/>
-      <p:bldP spid="115" grpId="5"/>
+      <p:bldP spid="113" grpId="3" animBg="1"/>
+      <p:bldP spid="114" grpId="4" animBg="1"/>
+      <p:bldP spid="115" grpId="5" animBg="1"/>
       <p:bldP spid="116" grpId="6"/>
     </p:bldLst>
   </p:timing>
@@ -5901,7 +5915,7 @@
           <a:p>
             <a:fld id="{B7EB45DA-9A0D-DC49-8E02-F30A5DDC21C3}" type="slidenum">
               <a:rPr lang="en-US" smtClean="0"/>
-              <a:t>1</a:t>
+              <a:t>12</a:t>
             </a:fld>
             <a:endParaRPr lang="en-US"/>
           </a:p>
@@ -5942,6 +5956,13 @@
             </a:solidFill>
           </a:ln>
         </p:spPr>
+        <p:txBody>
+          <a:bodyPr/>
+          <a:lstStyle/>
+          <a:p>
+            <a:endParaRPr lang="en-US"/>
+          </a:p>
+        </p:txBody>
       </p:sp>
       <p:sp>
         <p:nvSpPr>
@@ -5978,6 +5999,13 @@
             </a:solidFill>
           </a:ln>
         </p:spPr>
+        <p:txBody>
+          <a:bodyPr/>
+          <a:lstStyle/>
+          <a:p>
+            <a:endParaRPr lang="en-US"/>
+          </a:p>
+        </p:txBody>
       </p:sp>
       <p:sp>
         <p:nvSpPr>
@@ -6641,7 +6669,7 @@
       </p:sp>
       <p:sp>
         <p:nvSpPr>
-          <p:cNvPr id="113" name="FooterBand"/>
+          <p:cNvPr id="4" name="FooterBand"/>
           <p:cNvSpPr/>
           <p:nvPr/>
         </p:nvSpPr>
@@ -6692,19 +6720,19 @@
               <p:cTn id="2" dur="indefinite" nodeType="mainSeq">
                 <p:childTnLst>
                   <p:par>
-                    <p:cTn id="21" fill="hold">
+                    <p:cTn id="3" fill="hold">
                       <p:stCondLst>
                         <p:cond delay="indefinite"/>
                       </p:stCondLst>
                       <p:childTnLst>
                         <p:par>
-                          <p:cTn id="5" fill="hold">
+                          <p:cTn id="4" fill="hold">
                             <p:stCondLst>
                               <p:cond delay="0"/>
                             </p:stCondLst>
                             <p:childTnLst>
                               <p:par>
-                                <p:cTn id="8" presetID="10" presetClass="entr" presetSubtype="0" fill="hold" grpId="0" nodeType="clickEffect">
+                                <p:cTn id="5" presetID="10" presetClass="entr" presetSubtype="0" fill="hold" grpId="0" nodeType="clickEffect">
                                   <p:stCondLst>
                                     <p:cond delay="0"/>
                                   </p:stCondLst>
@@ -6742,13 +6770,13 @@
                           </p:cTn>
                         </p:par>
                         <p:par>
-                          <p:cTn id="9" fill="hold">
+                          <p:cTn id="8" fill="hold">
                             <p:stCondLst>
                               <p:cond delay="0"/>
                             </p:stCondLst>
                             <p:childTnLst>
                               <p:par>
-                                <p:cTn id="12" presetID="10" presetClass="entr" presetSubtype="0" fill="hold" grpId="1" nodeType="withEffect">
+                                <p:cTn id="9" presetID="10" presetClass="entr" presetSubtype="0" fill="hold" grpId="1" nodeType="withEffect">
                                   <p:stCondLst>
                                     <p:cond delay="0"/>
                                   </p:stCondLst>
@@ -6786,13 +6814,13 @@
                           </p:cTn>
                         </p:par>
                         <p:par>
-                          <p:cTn id="13" fill="hold">
+                          <p:cTn id="12" fill="hold">
                             <p:stCondLst>
                               <p:cond delay="0"/>
                             </p:stCondLst>
                             <p:childTnLst>
                               <p:par>
-                                <p:cTn id="16" presetID="10" presetClass="entr" presetSubtype="0" fill="hold" grpId="2" nodeType="withEffect">
+                                <p:cTn id="13" presetID="10" presetClass="entr" presetSubtype="0" fill="hold" grpId="2" nodeType="withEffect">
                                   <p:stCondLst>
                                     <p:cond delay="0"/>
                                   </p:stCondLst>
@@ -6830,13 +6858,13 @@
                           </p:cTn>
                         </p:par>
                         <p:par>
-                          <p:cTn id="17" fill="hold">
+                          <p:cTn id="16" fill="hold">
                             <p:stCondLst>
                               <p:cond delay="0"/>
                             </p:stCondLst>
                             <p:childTnLst>
                               <p:par>
-                                <p:cTn id="20" presetID="10" presetClass="entr" presetSubtype="0" fill="hold" grpId="3" nodeType="withEffect">
+                                <p:cTn id="17" presetID="10" presetClass="entr" presetSubtype="0" fill="hold" grpId="3" nodeType="withEffect">
                                   <p:stCondLst>
                                     <p:cond delay="0"/>
                                   </p:stCondLst>
@@ -6877,19 +6905,19 @@
                     </p:cTn>
                   </p:par>
                   <p:par>
-                    <p:cTn id="38" fill="hold">
+                    <p:cTn id="20" fill="hold">
                       <p:stCondLst>
                         <p:cond delay="indefinite"/>
                       </p:stCondLst>
                       <p:childTnLst>
                         <p:par>
-                          <p:cTn id="22" fill="hold">
+                          <p:cTn id="21" fill="hold">
                             <p:stCondLst>
                               <p:cond delay="0"/>
                             </p:stCondLst>
                             <p:childTnLst>
                               <p:par>
-                                <p:cTn id="25" presetID="10" presetClass="entr" presetSubtype="0" fill="hold" grpId="4" nodeType="clickEffect">
+                                <p:cTn id="22" presetID="10" presetClass="entr" presetSubtype="0" fill="hold" grpId="4" nodeType="clickEffect">
                                   <p:stCondLst>
                                     <p:cond delay="0"/>
                                   </p:stCondLst>
@@ -6927,13 +6955,13 @@
                           </p:cTn>
                         </p:par>
                         <p:par>
-                          <p:cTn id="26" fill="hold">
+                          <p:cTn id="25" fill="hold">
                             <p:stCondLst>
                               <p:cond delay="0"/>
                             </p:stCondLst>
                             <p:childTnLst>
                               <p:par>
-                                <p:cTn id="29" presetID="10" presetClass="entr" presetSubtype="0" fill="hold" grpId="5" nodeType="withEffect">
+                                <p:cTn id="26" presetID="10" presetClass="entr" presetSubtype="0" fill="hold" grpId="5" nodeType="withEffect">
                                   <p:stCondLst>
                                     <p:cond delay="0"/>
                                   </p:stCondLst>
@@ -6971,13 +6999,13 @@
                           </p:cTn>
                         </p:par>
                         <p:par>
-                          <p:cTn id="30" fill="hold">
+                          <p:cTn id="29" fill="hold">
                             <p:stCondLst>
                               <p:cond delay="0"/>
                             </p:stCondLst>
                             <p:childTnLst>
                               <p:par>
-                                <p:cTn id="33" presetID="10" presetClass="entr" presetSubtype="0" fill="hold" grpId="6" nodeType="withEffect">
+                                <p:cTn id="30" presetID="10" presetClass="entr" presetSubtype="0" fill="hold" grpId="6" nodeType="withEffect">
                                   <p:stCondLst>
                                     <p:cond delay="0"/>
                                   </p:stCondLst>
@@ -7015,13 +7043,13 @@
                           </p:cTn>
                         </p:par>
                         <p:par>
-                          <p:cTn id="34" fill="hold">
+                          <p:cTn id="33" fill="hold">
                             <p:stCondLst>
                               <p:cond delay="0"/>
                             </p:stCondLst>
                             <p:childTnLst>
                               <p:par>
-                                <p:cTn id="37" presetID="10" presetClass="entr" presetSubtype="0" fill="hold" grpId="7" nodeType="withEffect">
+                                <p:cTn id="34" presetID="10" presetClass="entr" presetSubtype="0" fill="hold" grpId="7" nodeType="withEffect">
                                   <p:stCondLst>
                                     <p:cond delay="0"/>
                                   </p:stCondLst>
@@ -7167,7 +7195,7 @@
           <a:p>
             <a:fld id="{B7EB45DA-9A0D-DC49-8E02-F30A5DDC21C3}" type="slidenum">
               <a:rPr lang="en-US" smtClean="0"/>
-              <a:t>1</a:t>
+              <a:t>13</a:t>
             </a:fld>
             <a:endParaRPr lang="en-US"/>
           </a:p>
@@ -7648,7 +7676,7 @@
           <a:p>
             <a:fld id="{B7EB45DA-9A0D-DC49-8E02-F30A5DDC21C3}" type="slidenum">
               <a:rPr lang="en-US" smtClean="0"/>
-              <a:t>1</a:t>
+              <a:t>14</a:t>
             </a:fld>
             <a:endParaRPr lang="en-US"/>
           </a:p>
@@ -7932,7 +7960,7 @@
           <a:p>
             <a:fld id="{B7EB45DA-9A0D-DC49-8E02-F30A5DDC21C3}" type="slidenum">
               <a:rPr lang="en-US" smtClean="0"/>
-              <a:t>1</a:t>
+              <a:t>15</a:t>
             </a:fld>
             <a:endParaRPr lang="en-US"/>
           </a:p>
@@ -8351,7 +8379,7 @@
           <a:p>
             <a:fld id="{B7EB45DA-9A0D-DC49-8E02-F30A5DDC21C3}" type="slidenum">
               <a:rPr lang="en-US" smtClean="0"/>
-              <a:t>1</a:t>
+              <a:t>16</a:t>
             </a:fld>
             <a:endParaRPr lang="en-US"/>
           </a:p>
@@ -8953,7 +8981,7 @@
       </p:sp>
       <p:sp>
         <p:nvSpPr>
-          <p:cNvPr id="113" name="FooterBand"/>
+          <p:cNvPr id="4" name="FooterBand"/>
           <p:cNvSpPr/>
           <p:nvPr/>
         </p:nvSpPr>
@@ -9069,7 +9097,7 @@
           <a:p>
             <a:fld id="{B7EB45DA-9A0D-DC49-8E02-F30A5DDC21C3}" type="slidenum">
               <a:rPr lang="en-US" smtClean="0"/>
-              <a:t>1</a:t>
+              <a:t>17</a:t>
             </a:fld>
             <a:endParaRPr lang="en-US"/>
           </a:p>
@@ -9349,7 +9377,7 @@
         </p:spPr>
         <p:txBody>
           <a:bodyPr>
-            <a:normAutofit fontScale="90000"/>
+            <a:normAutofit/>
           </a:bodyPr>
           <a:lstStyle/>
           <a:p>
@@ -9385,7 +9413,7 @@
           <a:p>
             <a:fld id="{B7EB45DA-9A0D-DC49-8E02-F30A5DDC21C3}" type="slidenum">
               <a:rPr lang="en-US" smtClean="0"/>
-              <a:t>1</a:t>
+              <a:t>18</a:t>
             </a:fld>
             <a:endParaRPr lang="en-US"/>
           </a:p>
@@ -9576,7 +9604,7 @@
           <a:p>
             <a:fld id="{B7EB45DA-9A0D-DC49-8E02-F30A5DDC21C3}" type="slidenum">
               <a:rPr lang="en-US" smtClean="0"/>
-              <a:t>1</a:t>
+              <a:t>19</a:t>
             </a:fld>
             <a:endParaRPr lang="en-US"/>
           </a:p>
@@ -9955,7 +9983,7 @@
         </p:spPr>
         <p:txBody>
           <a:bodyPr>
-            <a:normAutofit fontScale="90000"/>
+            <a:normAutofit/>
           </a:bodyPr>
           <a:lstStyle/>
           <a:p>
@@ -9991,7 +10019,7 @@
           <a:p>
             <a:fld id="{B7EB45DA-9A0D-DC49-8E02-F30A5DDC21C3}" type="slidenum">
               <a:rPr lang="en-US" smtClean="0"/>
-              <a:t>1</a:t>
+              <a:t>2</a:t>
             </a:fld>
             <a:endParaRPr lang="en-US"/>
           </a:p>
@@ -10182,7 +10210,7 @@
           <a:p>
             <a:fld id="{B7EB45DA-9A0D-DC49-8E02-F30A5DDC21C3}" type="slidenum">
               <a:rPr lang="en-US" smtClean="0"/>
-              <a:t>1</a:t>
+              <a:t>20</a:t>
             </a:fld>
             <a:endParaRPr lang="en-US"/>
           </a:p>
@@ -10550,7 +10578,7 @@
           <a:p>
             <a:fld id="{B7EB45DA-9A0D-DC49-8E02-F30A5DDC21C3}" type="slidenum">
               <a:rPr lang="en-US" smtClean="0"/>
-              <a:t>1</a:t>
+              <a:t>21</a:t>
             </a:fld>
             <a:endParaRPr lang="en-US"/>
           </a:p>
@@ -10918,7 +10946,7 @@
           <a:p>
             <a:fld id="{B7EB45DA-9A0D-DC49-8E02-F30A5DDC21C3}" type="slidenum">
               <a:rPr lang="en-US" smtClean="0"/>
-              <a:t>1</a:t>
+              <a:t>22</a:t>
             </a:fld>
             <a:endParaRPr lang="en-US"/>
           </a:p>
@@ -11353,7 +11381,7 @@
           <a:p>
             <a:fld id="{B7EB45DA-9A0D-DC49-8E02-F30A5DDC21C3}" type="slidenum">
               <a:rPr lang="en-US" smtClean="0"/>
-              <a:t>1</a:t>
+              <a:t>23</a:t>
             </a:fld>
             <a:endParaRPr lang="en-US"/>
           </a:p>
@@ -11721,7 +11749,7 @@
           <a:p>
             <a:fld id="{B7EB45DA-9A0D-DC49-8E02-F30A5DDC21C3}" type="slidenum">
               <a:rPr lang="en-US" smtClean="0"/>
-              <a:t>1</a:t>
+              <a:t>24</a:t>
             </a:fld>
             <a:endParaRPr lang="en-US"/>
           </a:p>
@@ -12089,7 +12117,7 @@
           <a:p>
             <a:fld id="{B7EB45DA-9A0D-DC49-8E02-F30A5DDC21C3}" type="slidenum">
               <a:rPr lang="en-US" smtClean="0"/>
-              <a:t>1</a:t>
+              <a:t>25</a:t>
             </a:fld>
             <a:endParaRPr lang="en-US"/>
           </a:p>
@@ -12457,7 +12485,7 @@
           <a:p>
             <a:fld id="{B7EB45DA-9A0D-DC49-8E02-F30A5DDC21C3}" type="slidenum">
               <a:rPr lang="en-US" smtClean="0"/>
-              <a:t>1</a:t>
+              <a:t>26</a:t>
             </a:fld>
             <a:endParaRPr lang="en-US"/>
           </a:p>
@@ -12825,7 +12853,7 @@
           <a:p>
             <a:fld id="{B7EB45DA-9A0D-DC49-8E02-F30A5DDC21C3}" type="slidenum">
               <a:rPr lang="en-US" smtClean="0"/>
-              <a:t>1</a:t>
+              <a:t>27</a:t>
             </a:fld>
             <a:endParaRPr lang="en-US"/>
           </a:p>
@@ -13241,7 +13269,7 @@
         </p:spPr>
         <p:txBody>
           <a:bodyPr>
-            <a:normAutofit fontScale="90000"/>
+            <a:normAutofit/>
           </a:bodyPr>
           <a:lstStyle/>
           <a:p>
@@ -13277,7 +13305,7 @@
           <a:p>
             <a:fld id="{B7EB45DA-9A0D-DC49-8E02-F30A5DDC21C3}" type="slidenum">
               <a:rPr lang="en-US" smtClean="0"/>
-              <a:t>1</a:t>
+              <a:t>28</a:t>
             </a:fld>
             <a:endParaRPr lang="en-US"/>
           </a:p>
@@ -13468,7 +13496,7 @@
           <a:p>
             <a:fld id="{B7EB45DA-9A0D-DC49-8E02-F30A5DDC21C3}" type="slidenum">
               <a:rPr lang="en-US" smtClean="0"/>
-              <a:t>1</a:t>
+              <a:t>29</a:t>
             </a:fld>
             <a:endParaRPr lang="en-US"/>
           </a:p>
@@ -13757,7 +13785,7 @@
           <a:p>
             <a:fld id="{B7EB45DA-9A0D-DC49-8E02-F30A5DDC21C3}" type="slidenum">
               <a:rPr lang="en-US" smtClean="0"/>
-              <a:t>1</a:t>
+              <a:t>3</a:t>
             </a:fld>
             <a:endParaRPr lang="en-US"/>
           </a:p>
@@ -13908,7 +13936,7 @@
               <a:buNone/>
             </a:pPr>
             <a:r>
-              <a:rPr lang="en-US" sz="1500" b="0" i="1" dirty="0">
+              <a:rPr lang="en-US" b="0" i="1" dirty="0">
                 <a:solidFill>
                   <a:srgbClr val="555960"/>
                 </a:solidFill>
@@ -13967,8 +13995,8 @@
         </p:nvSpPr>
         <p:spPr>
           <a:xfrm>
-            <a:off x="685800" y="4460000"/>
-            <a:ext cx="7772400" cy="900000"/>
+            <a:off x="514350" y="4502160"/>
+            <a:ext cx="8001000" cy="900000"/>
           </a:xfrm>
           <a:prstGeom prst="rect">
             <a:avLst/>
@@ -13979,19 +14007,19 @@
           </a:ln>
         </p:spPr>
         <p:txBody>
-          <a:bodyPr wrap="square" lIns="0" tIns="0" rIns="0" bIns="0" anchor="t"/>
-          <a:lstStyle/>
-          <a:p>
-            <a:pPr algn="ctr">
-              <a:buNone/>
-            </a:pPr>
-            <a:r>
-              <a:rPr lang="en-US" sz="1700" b="0" i="1" dirty="0">
+          <a:bodyPr wrap="square" lIns="0" tIns="0" rIns="0" bIns="0" anchor="ctr"/>
+          <a:lstStyle/>
+          <a:p>
+            <a:pPr algn="ctr">
+              <a:buNone/>
+            </a:pPr>
+            <a:r>
+              <a:rPr lang="en-US" sz="2000" b="0" i="1" dirty="0">
                 <a:solidFill>
                   <a:srgbClr val="555960"/>
                 </a:solidFill>
               </a:rPr>
-              <a:t>Validation is the discipline of building this argument — and judging whether it is strong enough for what is at stake.</a:t>
+              <a:t>Validation is the discipline of building the appropriate argument for the claim</a:t>
             </a:r>
           </a:p>
         </p:txBody>
@@ -14114,7 +14142,7 @@
           <a:p>
             <a:fld id="{B7EB45DA-9A0D-DC49-8E02-F30A5DDC21C3}" type="slidenum">
               <a:rPr lang="en-US" smtClean="0"/>
-              <a:t>1</a:t>
+              <a:t>30</a:t>
             </a:fld>
             <a:endParaRPr lang="en-US"/>
           </a:p>
@@ -14196,86 +14224,13 @@
       </p:sp>
       <p:sp>
         <p:nvSpPr>
-          <p:cNvPr id="101" name="TPSbadge"/>
-          <p:cNvSpPr/>
-          <p:nvPr/>
-        </p:nvSpPr>
-        <p:spPr>
-          <a:xfrm>
-            <a:off x="2972000" y="2260000"/>
-            <a:ext cx="3200000" cy="640000"/>
-          </a:xfrm>
-          <a:prstGeom prst="roundRect">
-            <a:avLst/>
-          </a:prstGeom>
-          <a:solidFill>
-            <a:srgbClr val="FBF8F2"/>
-          </a:solidFill>
-          <a:ln w="15875">
-            <a:solidFill>
-              <a:srgbClr val="8E6F3E"/>
-            </a:solidFill>
-          </a:ln>
-        </p:spPr>
-        <p:txBody>
-          <a:bodyPr wrap="square" lIns="91440" tIns="45720" rIns="91440" bIns="45720" anchor="ctr"/>
-          <a:lstStyle/>
-          <a:p>
-            <a:pPr algn="ctr">
-              <a:buNone/>
-            </a:pPr>
-            <a:r>
-              <a:rPr lang="en-US" sz="2200" b="1" i="0" dirty="0">
-                <a:solidFill>
-                  <a:srgbClr val="6B3FA0"/>
-                </a:solidFill>
-              </a:rPr>
-              <a:t>THINK</a:t>
-            </a:r>
-            <a:r>
-              <a:rPr lang="en-US" sz="2200" b="1" i="0" dirty="0">
-                <a:solidFill>
-                  <a:srgbClr val="9A9A9A"/>
-                </a:solidFill>
-              </a:rPr>
-              <a:t xml:space="preserve">  ·  </a:t>
-            </a:r>
-            <a:r>
-              <a:rPr lang="en-US" sz="2200" b="1" i="0" dirty="0">
-                <a:solidFill>
-                  <a:srgbClr val="2E74B5"/>
-                </a:solidFill>
-              </a:rPr>
-              <a:t>PAIR</a:t>
-            </a:r>
-            <a:r>
-              <a:rPr lang="en-US" sz="2200" b="1" i="0" dirty="0">
-                <a:solidFill>
-                  <a:srgbClr val="9A9A9A"/>
-                </a:solidFill>
-              </a:rPr>
-              <a:t xml:space="preserve">  ·  </a:t>
-            </a:r>
-            <a:r>
-              <a:rPr lang="en-US" sz="2200" b="1" i="0" dirty="0">
-                <a:solidFill>
-                  <a:srgbClr val="B8860B"/>
-                </a:solidFill>
-              </a:rPr>
-              <a:t>SHARE</a:t>
-            </a:r>
-          </a:p>
-        </p:txBody>
-      </p:sp>
-      <p:sp>
-        <p:nvSpPr>
           <p:cNvPr id="102" name="T102"/>
           <p:cNvSpPr txBox="1"/>
           <p:nvPr/>
         </p:nvSpPr>
         <p:spPr>
           <a:xfrm>
-            <a:off x="685800" y="3080000"/>
+            <a:off x="685800" y="3537201"/>
             <a:ext cx="7772400" cy="460000"/>
           </a:xfrm>
           <a:prstGeom prst="rect">
@@ -14312,7 +14267,7 @@
         </p:nvSpPr>
         <p:spPr>
           <a:xfrm>
-            <a:off x="1372000" y="3620000"/>
+            <a:off x="1372000" y="4077201"/>
             <a:ext cx="6400000" cy="1080000"/>
           </a:xfrm>
           <a:prstGeom prst="rect">
@@ -14400,6 +14355,36 @@
           </a:p>
         </p:txBody>
       </p:sp>
+      <p:pic>
+        <p:nvPicPr>
+          <p:cNvPr id="4" name="Think Pair Share banner" descr="Think, Pair, Share">
+            <a:extLst>
+              <a:ext uri="{FF2B5EF4-FFF2-40B4-BE49-F238E27FC236}">
+                <a16:creationId xmlns:a16="http://schemas.microsoft.com/office/drawing/2014/main" id="{4153810E-47AC-3B70-1311-0F23CAE82167}"/>
+              </a:ext>
+            </a:extLst>
+          </p:cNvPr>
+          <p:cNvPicPr>
+            <a:picLocks noChangeAspect="1"/>
+          </p:cNvPicPr>
+          <p:nvPr/>
+        </p:nvPicPr>
+        <p:blipFill>
+          <a:blip r:embed="rId2"/>
+          <a:stretch>
+            <a:fillRect/>
+          </a:stretch>
+        </p:blipFill>
+        <p:spPr>
+          <a:xfrm>
+            <a:off x="2476500" y="2153804"/>
+            <a:ext cx="4191000" cy="1206500"/>
+          </a:xfrm>
+          <a:prstGeom prst="rect">
+            <a:avLst/>
+          </a:prstGeom>
+        </p:spPr>
+      </p:pic>
     </p:spTree>
   </p:cSld>
   <p:clrMapOvr>
@@ -14414,19 +14399,19 @@
               <p:cTn id="2" dur="indefinite" nodeType="mainSeq">
                 <p:childTnLst>
                   <p:par>
-                    <p:cTn id="9" fill="hold">
+                    <p:cTn id="3" fill="hold">
                       <p:stCondLst>
                         <p:cond delay="indefinite"/>
                       </p:stCondLst>
                       <p:childTnLst>
                         <p:par>
-                          <p:cTn id="5" fill="hold">
+                          <p:cTn id="4" fill="hold">
                             <p:stCondLst>
                               <p:cond delay="0"/>
                             </p:stCondLst>
                             <p:childTnLst>
                               <p:par>
-                                <p:cTn id="8" presetID="10" presetClass="entr" presetSubtype="0" fill="hold" grpId="0" nodeType="clickEffect">
+                                <p:cTn id="5" presetID="10" presetClass="entr" presetSubtype="0" fill="hold" grpId="0" nodeType="clickEffect">
                                   <p:stCondLst>
                                     <p:cond delay="0"/>
                                   </p:stCondLst>
@@ -14488,7 +14473,7 @@
       </p:par>
     </p:tnLst>
     <p:bldLst>
-      <p:bldP spid="103" grpId="0"/>
+      <p:bldP spid="103" grpId="0" animBg="1"/>
     </p:bldLst>
   </p:timing>
 </p:sld>
@@ -14565,7 +14550,7 @@
           <a:p>
             <a:fld id="{B7EB45DA-9A0D-DC49-8E02-F30A5DDC21C3}" type="slidenum">
               <a:rPr lang="en-US" smtClean="0"/>
-              <a:t>1</a:t>
+              <a:t>31</a:t>
             </a:fld>
             <a:endParaRPr lang="en-US"/>
           </a:p>
@@ -14869,7 +14854,7 @@
           <a:p>
             <a:fld id="{B7EB45DA-9A0D-DC49-8E02-F30A5DDC21C3}" type="slidenum">
               <a:rPr lang="en-US" smtClean="0"/>
-              <a:t>1</a:t>
+              <a:t>32</a:t>
             </a:fld>
             <a:endParaRPr lang="en-US"/>
           </a:p>
@@ -15287,6 +15272,13 @@
             <a:tailEnd type="triangle" w="med" len="med"/>
           </a:ln>
         </p:spPr>
+        <p:txBody>
+          <a:bodyPr/>
+          <a:lstStyle/>
+          <a:p>
+            <a:endParaRPr lang="en-US"/>
+          </a:p>
+        </p:txBody>
       </p:sp>
       <p:sp>
         <p:nvSpPr>
@@ -15327,6 +15319,13 @@
             <a:tailEnd type="triangle" w="med" len="med"/>
           </a:ln>
         </p:spPr>
+        <p:txBody>
+          <a:bodyPr/>
+          <a:lstStyle/>
+          <a:p>
+            <a:endParaRPr lang="en-US"/>
+          </a:p>
+        </p:txBody>
       </p:sp>
       <p:sp>
         <p:nvSpPr>
@@ -15367,7 +15366,7 @@
       </p:sp>
       <p:sp>
         <p:nvSpPr>
-          <p:cNvPr id="113" name="FooterBand"/>
+          <p:cNvPr id="4" name="FooterBand"/>
           <p:cNvSpPr/>
           <p:nvPr/>
         </p:nvSpPr>
@@ -15463,7 +15462,7 @@
         </p:spPr>
         <p:txBody>
           <a:bodyPr>
-            <a:normAutofit fontScale="90000"/>
+            <a:normAutofit/>
           </a:bodyPr>
           <a:lstStyle/>
           <a:p>
@@ -15499,7 +15498,7 @@
           <a:p>
             <a:fld id="{B7EB45DA-9A0D-DC49-8E02-F30A5DDC21C3}" type="slidenum">
               <a:rPr lang="en-US" smtClean="0"/>
-              <a:t>1</a:t>
+              <a:t>33</a:t>
             </a:fld>
             <a:endParaRPr lang="en-US"/>
           </a:p>
@@ -15690,7 +15689,7 @@
           <a:p>
             <a:fld id="{B7EB45DA-9A0D-DC49-8E02-F30A5DDC21C3}" type="slidenum">
               <a:rPr lang="en-US" smtClean="0"/>
-              <a:t>1</a:t>
+              <a:t>34</a:t>
             </a:fld>
             <a:endParaRPr lang="en-US"/>
           </a:p>
@@ -15985,7 +15984,7 @@
           <a:p>
             <a:fld id="{B7EB45DA-9A0D-DC49-8E02-F30A5DDC21C3}" type="slidenum">
               <a:rPr lang="en-US" smtClean="0"/>
-              <a:t>1</a:t>
+              <a:t>35</a:t>
             </a:fld>
             <a:endParaRPr lang="en-US"/>
           </a:p>
@@ -16066,86 +16065,13 @@
       </p:sp>
       <p:sp>
         <p:nvSpPr>
-          <p:cNvPr id="101" name="TPSbadge"/>
-          <p:cNvSpPr/>
-          <p:nvPr/>
-        </p:nvSpPr>
-        <p:spPr>
-          <a:xfrm>
-            <a:off x="2972000" y="2320000"/>
-            <a:ext cx="3200000" cy="560000"/>
-          </a:xfrm>
-          <a:prstGeom prst="roundRect">
-            <a:avLst/>
-          </a:prstGeom>
-          <a:solidFill>
-            <a:srgbClr val="FBF8F2"/>
-          </a:solidFill>
-          <a:ln w="15875">
-            <a:solidFill>
-              <a:srgbClr val="8E6F3E"/>
-            </a:solidFill>
-          </a:ln>
-        </p:spPr>
-        <p:txBody>
-          <a:bodyPr wrap="square" lIns="91440" tIns="45720" rIns="91440" bIns="45720" anchor="ctr"/>
-          <a:lstStyle/>
-          <a:p>
-            <a:pPr algn="ctr">
-              <a:buNone/>
-            </a:pPr>
-            <a:r>
-              <a:rPr lang="en-US" sz="2200" b="1" i="0" dirty="0">
-                <a:solidFill>
-                  <a:srgbClr val="6B3FA0"/>
-                </a:solidFill>
-              </a:rPr>
-              <a:t>THINK</a:t>
-            </a:r>
-            <a:r>
-              <a:rPr lang="en-US" sz="2200" b="1" i="0" dirty="0">
-                <a:solidFill>
-                  <a:srgbClr val="9A9A9A"/>
-                </a:solidFill>
-              </a:rPr>
-              <a:t xml:space="preserve">  ·  </a:t>
-            </a:r>
-            <a:r>
-              <a:rPr lang="en-US" sz="2200" b="1" i="0" dirty="0">
-                <a:solidFill>
-                  <a:srgbClr val="2E74B5"/>
-                </a:solidFill>
-              </a:rPr>
-              <a:t>PAIR</a:t>
-            </a:r>
-            <a:r>
-              <a:rPr lang="en-US" sz="2200" b="1" i="0" dirty="0">
-                <a:solidFill>
-                  <a:srgbClr val="9A9A9A"/>
-                </a:solidFill>
-              </a:rPr>
-              <a:t xml:space="preserve">  ·  </a:t>
-            </a:r>
-            <a:r>
-              <a:rPr lang="en-US" sz="2200" b="1" i="0" dirty="0">
-                <a:solidFill>
-                  <a:srgbClr val="B8860B"/>
-                </a:solidFill>
-              </a:rPr>
-              <a:t>SHARE</a:t>
-            </a:r>
-          </a:p>
-        </p:txBody>
-      </p:sp>
-      <p:sp>
-        <p:nvSpPr>
           <p:cNvPr id="110" name="B110"/>
           <p:cNvSpPr/>
           <p:nvPr/>
         </p:nvSpPr>
         <p:spPr>
           <a:xfrm>
-            <a:off x="432000" y="3120000"/>
+            <a:off x="432000" y="3736227"/>
             <a:ext cx="1560000" cy="820000"/>
           </a:xfrm>
           <a:prstGeom prst="rect">
@@ -16184,7 +16110,7 @@
         </p:nvSpPr>
         <p:spPr>
           <a:xfrm>
-            <a:off x="2112000" y="3120000"/>
+            <a:off x="2112000" y="3736227"/>
             <a:ext cx="1560000" cy="820000"/>
           </a:xfrm>
           <a:prstGeom prst="rect">
@@ -16223,7 +16149,7 @@
         </p:nvSpPr>
         <p:spPr>
           <a:xfrm>
-            <a:off x="3792000" y="3120000"/>
+            <a:off x="3792000" y="3736227"/>
             <a:ext cx="1560000" cy="820000"/>
           </a:xfrm>
           <a:prstGeom prst="rect">
@@ -16262,7 +16188,7 @@
         </p:nvSpPr>
         <p:spPr>
           <a:xfrm>
-            <a:off x="5472000" y="3120000"/>
+            <a:off x="5472000" y="3736227"/>
             <a:ext cx="1560000" cy="820000"/>
           </a:xfrm>
           <a:prstGeom prst="rect">
@@ -16301,7 +16227,7 @@
         </p:nvSpPr>
         <p:spPr>
           <a:xfrm>
-            <a:off x="7152000" y="3120000"/>
+            <a:off x="7152000" y="3736227"/>
             <a:ext cx="1560000" cy="820000"/>
           </a:xfrm>
           <a:prstGeom prst="rect">
@@ -16340,7 +16266,7 @@
         </p:nvSpPr>
         <p:spPr>
           <a:xfrm>
-            <a:off x="620000" y="4100000"/>
+            <a:off x="620000" y="4716227"/>
             <a:ext cx="8000000" cy="520000"/>
           </a:xfrm>
           <a:prstGeom prst="rect">
@@ -16371,7 +16297,7 @@
       </p:sp>
       <p:sp>
         <p:nvSpPr>
-          <p:cNvPr id="113" name="FooterBand"/>
+          <p:cNvPr id="4" name="FooterBand"/>
           <p:cNvSpPr/>
           <p:nvPr/>
         </p:nvSpPr>
@@ -16408,6 +16334,36 @@
           </a:p>
         </p:txBody>
       </p:sp>
+      <p:pic>
+        <p:nvPicPr>
+          <p:cNvPr id="7" name="Think Pair Share banner" descr="Think, Pair, Share">
+            <a:extLst>
+              <a:ext uri="{FF2B5EF4-FFF2-40B4-BE49-F238E27FC236}">
+                <a16:creationId xmlns:a16="http://schemas.microsoft.com/office/drawing/2014/main" id="{0EFA98E1-0C18-D839-ECB8-B98ADB983623}"/>
+              </a:ext>
+            </a:extLst>
+          </p:cNvPr>
+          <p:cNvPicPr>
+            <a:picLocks noChangeAspect="1"/>
+          </p:cNvPicPr>
+          <p:nvPr/>
+        </p:nvPicPr>
+        <p:blipFill>
+          <a:blip r:embed="rId2"/>
+          <a:stretch>
+            <a:fillRect/>
+          </a:stretch>
+        </p:blipFill>
+        <p:spPr>
+          <a:xfrm>
+            <a:off x="2524500" y="2332830"/>
+            <a:ext cx="4191000" cy="1206500"/>
+          </a:xfrm>
+          <a:prstGeom prst="rect">
+            <a:avLst/>
+          </a:prstGeom>
+        </p:spPr>
+      </p:pic>
     </p:spTree>
   </p:cSld>
   <p:clrMapOvr>
@@ -16422,19 +16378,19 @@
               <p:cTn id="2" dur="indefinite" nodeType="mainSeq">
                 <p:childTnLst>
                   <p:par>
-                    <p:cTn id="25" fill="hold">
+                    <p:cTn id="3" fill="hold">
                       <p:stCondLst>
                         <p:cond delay="indefinite"/>
                       </p:stCondLst>
                       <p:childTnLst>
                         <p:par>
-                          <p:cTn id="5" fill="hold">
+                          <p:cTn id="4" fill="hold">
                             <p:stCondLst>
                               <p:cond delay="0"/>
                             </p:stCondLst>
                             <p:childTnLst>
                               <p:par>
-                                <p:cTn id="8" presetID="10" presetClass="entr" presetSubtype="0" fill="hold" grpId="0" nodeType="clickEffect">
+                                <p:cTn id="5" presetID="10" presetClass="entr" presetSubtype="0" fill="hold" grpId="0" nodeType="clickEffect">
                                   <p:stCondLst>
                                     <p:cond delay="0"/>
                                   </p:stCondLst>
@@ -16472,13 +16428,13 @@
                           </p:cTn>
                         </p:par>
                         <p:par>
-                          <p:cTn id="9" fill="hold">
+                          <p:cTn id="8" fill="hold">
                             <p:stCondLst>
                               <p:cond delay="0"/>
                             </p:stCondLst>
                             <p:childTnLst>
                               <p:par>
-                                <p:cTn id="12" presetID="10" presetClass="entr" presetSubtype="0" fill="hold" grpId="1" nodeType="withEffect">
+                                <p:cTn id="9" presetID="10" presetClass="entr" presetSubtype="0" fill="hold" grpId="1" nodeType="withEffect">
                                   <p:stCondLst>
                                     <p:cond delay="0"/>
                                   </p:stCondLst>
@@ -16516,13 +16472,13 @@
                           </p:cTn>
                         </p:par>
                         <p:par>
-                          <p:cTn id="13" fill="hold">
+                          <p:cTn id="12" fill="hold">
                             <p:stCondLst>
                               <p:cond delay="0"/>
                             </p:stCondLst>
                             <p:childTnLst>
                               <p:par>
-                                <p:cTn id="16" presetID="10" presetClass="entr" presetSubtype="0" fill="hold" grpId="2" nodeType="withEffect">
+                                <p:cTn id="13" presetID="10" presetClass="entr" presetSubtype="0" fill="hold" grpId="2" nodeType="withEffect">
                                   <p:stCondLst>
                                     <p:cond delay="0"/>
                                   </p:stCondLst>
@@ -16560,13 +16516,13 @@
                           </p:cTn>
                         </p:par>
                         <p:par>
-                          <p:cTn id="17" fill="hold">
+                          <p:cTn id="16" fill="hold">
                             <p:stCondLst>
                               <p:cond delay="0"/>
                             </p:stCondLst>
                             <p:childTnLst>
                               <p:par>
-                                <p:cTn id="20" presetID="10" presetClass="entr" presetSubtype="0" fill="hold" grpId="3" nodeType="withEffect">
+                                <p:cTn id="17" presetID="10" presetClass="entr" presetSubtype="0" fill="hold" grpId="3" nodeType="withEffect">
                                   <p:stCondLst>
                                     <p:cond delay="0"/>
                                   </p:stCondLst>
@@ -16604,13 +16560,13 @@
                           </p:cTn>
                         </p:par>
                         <p:par>
-                          <p:cTn id="21" fill="hold">
+                          <p:cTn id="20" fill="hold">
                             <p:stCondLst>
                               <p:cond delay="0"/>
                             </p:stCondLst>
                             <p:childTnLst>
                               <p:par>
-                                <p:cTn id="24" presetID="10" presetClass="entr" presetSubtype="0" fill="hold" grpId="4" nodeType="withEffect">
+                                <p:cTn id="21" presetID="10" presetClass="entr" presetSubtype="0" fill="hold" grpId="4" nodeType="withEffect">
                                   <p:stCondLst>
                                     <p:cond delay="0"/>
                                   </p:stCondLst>
@@ -16672,11 +16628,11 @@
       </p:par>
     </p:tnLst>
     <p:bldLst>
-      <p:bldP spid="110" grpId="0"/>
-      <p:bldP spid="111" grpId="1"/>
-      <p:bldP spid="112" grpId="2"/>
-      <p:bldP spid="113" grpId="3"/>
-      <p:bldP spid="114" grpId="4"/>
+      <p:bldP spid="110" grpId="0" animBg="1"/>
+      <p:bldP spid="111" grpId="1" animBg="1"/>
+      <p:bldP spid="112" grpId="2" animBg="1"/>
+      <p:bldP spid="113" grpId="3" animBg="1"/>
+      <p:bldP spid="114" grpId="4" animBg="1"/>
     </p:bldLst>
   </p:timing>
 </p:sld>
@@ -16753,7 +16709,7 @@
           <a:p>
             <a:fld id="{B7EB45DA-9A0D-DC49-8E02-F30A5DDC21C3}" type="slidenum">
               <a:rPr lang="en-US" smtClean="0"/>
-              <a:t>1</a:t>
+              <a:t>36</a:t>
             </a:fld>
             <a:endParaRPr lang="en-US"/>
           </a:p>
@@ -16797,86 +16753,6 @@
             </a:r>
           </a:p>
         </p:txBody>
-      </p:sp>
-      <p:sp>
-        <p:nvSpPr>
-          <p:cNvPr id="101" name="L101"/>
-          <p:cNvSpPr/>
-          <p:nvPr/>
-        </p:nvSpPr>
-        <p:spPr>
-          <a:xfrm>
-            <a:off x="2300000" y="1500000"/>
-            <a:ext cx="2272000" cy="360000"/>
-          </a:xfrm>
-          <a:custGeom>
-            <a:avLst/>
-            <a:gdLst/>
-            <a:ahLst/>
-            <a:cxnLst/>
-            <a:rect l="l" t="t" r="r" b="b"/>
-            <a:pathLst>
-              <a:path w="2272000" h="360000" fill="none">
-                <a:moveTo>
-                  <a:pt x="2272000" y="0"/>
-                </a:moveTo>
-                <a:lnTo>
-                  <a:pt x="0" y="0"/>
-                </a:lnTo>
-                <a:lnTo>
-                  <a:pt x="0" y="360000"/>
-                </a:lnTo>
-              </a:path>
-            </a:pathLst>
-          </a:custGeom>
-          <a:noFill/>
-          <a:ln w="38100">
-            <a:solidFill>
-              <a:srgbClr val="8E6F3E"/>
-            </a:solidFill>
-            <a:tailEnd type="triangle" w="med" len="med"/>
-          </a:ln>
-        </p:spPr>
-      </p:sp>
-      <p:sp>
-        <p:nvSpPr>
-          <p:cNvPr id="102" name="L102"/>
-          <p:cNvSpPr/>
-          <p:nvPr/>
-        </p:nvSpPr>
-        <p:spPr>
-          <a:xfrm>
-            <a:off x="4572000" y="1500000"/>
-            <a:ext cx="2272000" cy="360000"/>
-          </a:xfrm>
-          <a:custGeom>
-            <a:avLst/>
-            <a:gdLst/>
-            <a:ahLst/>
-            <a:cxnLst/>
-            <a:rect l="l" t="t" r="r" b="b"/>
-            <a:pathLst>
-              <a:path w="2272000" h="360000" fill="none">
-                <a:moveTo>
-                  <a:pt x="0" y="0"/>
-                </a:moveTo>
-                <a:lnTo>
-                  <a:pt x="2272000" y="0"/>
-                </a:lnTo>
-                <a:lnTo>
-                  <a:pt x="2272000" y="360000"/>
-                </a:lnTo>
-              </a:path>
-            </a:pathLst>
-          </a:custGeom>
-          <a:noFill/>
-          <a:ln w="38100">
-            <a:solidFill>
-              <a:srgbClr val="8E6F3E"/>
-            </a:solidFill>
-            <a:tailEnd type="triangle" w="med" len="med"/>
-          </a:ln>
-        </p:spPr>
       </p:sp>
       <p:sp>
         <p:nvSpPr>
@@ -17512,6 +17388,91 @@
           </a:p>
         </p:txBody>
       </p:sp>
+      <p:cxnSp>
+        <p:nvCxnSpPr>
+          <p:cNvPr id="5" name="Elbow Connector 4">
+            <a:extLst>
+              <a:ext uri="{FF2B5EF4-FFF2-40B4-BE49-F238E27FC236}">
+                <a16:creationId xmlns:a16="http://schemas.microsoft.com/office/drawing/2014/main" id="{782FD6B7-3E42-E711-C90C-27E6D1360FA6}"/>
+              </a:ext>
+            </a:extLst>
+          </p:cNvPr>
+          <p:cNvCxnSpPr>
+            <a:stCxn id="100" idx="1"/>
+            <a:endCxn id="110" idx="0"/>
+          </p:cNvCxnSpPr>
+          <p:nvPr/>
+        </p:nvCxnSpPr>
+        <p:spPr>
+          <a:xfrm rot="10800000" flipV="1">
+            <a:off x="2300000" y="1200000"/>
+            <a:ext cx="972000" cy="720000"/>
+          </a:xfrm>
+          <a:prstGeom prst="bentConnector2">
+            <a:avLst/>
+          </a:prstGeom>
+          <a:ln w="38100">
+            <a:tailEnd type="triangle"/>
+          </a:ln>
+        </p:spPr>
+        <p:style>
+          <a:lnRef idx="1">
+            <a:schemeClr val="accent1"/>
+          </a:lnRef>
+          <a:fillRef idx="0">
+            <a:schemeClr val="accent1"/>
+          </a:fillRef>
+          <a:effectRef idx="0">
+            <a:schemeClr val="accent1"/>
+          </a:effectRef>
+          <a:fontRef idx="minor">
+            <a:schemeClr val="tx1"/>
+          </a:fontRef>
+        </p:style>
+      </p:cxnSp>
+      <p:cxnSp>
+        <p:nvCxnSpPr>
+          <p:cNvPr id="6" name="Elbow Connector 5">
+            <a:extLst>
+              <a:ext uri="{FF2B5EF4-FFF2-40B4-BE49-F238E27FC236}">
+                <a16:creationId xmlns:a16="http://schemas.microsoft.com/office/drawing/2014/main" id="{21C0A1B5-59B7-1E91-456F-6E32303C7D37}"/>
+              </a:ext>
+            </a:extLst>
+          </p:cNvPr>
+          <p:cNvCxnSpPr>
+            <a:cxnSpLocks/>
+            <a:stCxn id="100" idx="3"/>
+            <a:endCxn id="111" idx="0"/>
+          </p:cNvCxnSpPr>
+          <p:nvPr/>
+        </p:nvCxnSpPr>
+        <p:spPr>
+          <a:xfrm>
+            <a:off x="5872000" y="1200000"/>
+            <a:ext cx="248000" cy="720000"/>
+          </a:xfrm>
+          <a:prstGeom prst="bentConnector2">
+            <a:avLst/>
+          </a:prstGeom>
+          <a:ln w="38100">
+            <a:tailEnd type="triangle"/>
+          </a:ln>
+        </p:spPr>
+        <p:style>
+          <a:lnRef idx="1">
+            <a:schemeClr val="accent1"/>
+          </a:lnRef>
+          <a:fillRef idx="0">
+            <a:schemeClr val="accent1"/>
+          </a:fillRef>
+          <a:effectRef idx="0">
+            <a:schemeClr val="accent1"/>
+          </a:effectRef>
+          <a:fontRef idx="minor">
+            <a:schemeClr val="tx1"/>
+          </a:fontRef>
+        </p:style>
+      </p:cxnSp>
     </p:spTree>
   </p:cSld>
   <p:clrMapOvr>
@@ -17591,7 +17552,7 @@
           <a:p>
             <a:fld id="{B7EB45DA-9A0D-DC49-8E02-F30A5DDC21C3}" type="slidenum">
               <a:rPr lang="en-US" smtClean="0"/>
-              <a:t>1</a:t>
+              <a:t>37</a:t>
             </a:fld>
             <a:endParaRPr lang="en-US"/>
           </a:p>
@@ -18008,7 +17969,7 @@
           <a:p>
             <a:fld id="{B7EB45DA-9A0D-DC49-8E02-F30A5DDC21C3}" type="slidenum">
               <a:rPr lang="en-US" smtClean="0"/>
-              <a:t>1</a:t>
+              <a:t>4</a:t>
             </a:fld>
             <a:endParaRPr lang="en-US"/>
           </a:p>
@@ -18022,8 +17983,8 @@
         </p:nvSpPr>
         <p:spPr>
           <a:xfrm>
-            <a:off x="685800" y="1500000"/>
-            <a:ext cx="7772400" cy="900000"/>
+            <a:off x="408948" y="3036911"/>
+            <a:ext cx="8458200" cy="900000"/>
           </a:xfrm>
           <a:prstGeom prst="rect">
             <a:avLst/>
@@ -18046,8 +18007,42 @@
                   <a:srgbClr val="000000"/>
                 </a:solidFill>
               </a:rPr>
-              <a:t>How confident must you be before delivering software?</a:t>
-            </a:r>
+              <a:t>How confident must you be before </a:t>
+            </a:r>
+            <a:r>
+              <a:rPr lang="en-US" sz="2800" dirty="0">
+                <a:solidFill>
+                  <a:srgbClr val="000000"/>
+                </a:solidFill>
+              </a:rPr>
+              <a:t>shipping a product</a:t>
+            </a:r>
+            <a:r>
+              <a:rPr lang="en-US" sz="2800" b="0" i="0" dirty="0">
+                <a:solidFill>
+                  <a:srgbClr val="000000"/>
+                </a:solidFill>
+              </a:rPr>
+              <a:t>?</a:t>
+            </a:r>
+          </a:p>
+          <a:p>
+            <a:pPr algn="ctr">
+              <a:buNone/>
+            </a:pPr>
+            <a:r>
+              <a:rPr lang="en-US" sz="2800" dirty="0">
+                <a:solidFill>
+                  <a:srgbClr val="000000"/>
+                </a:solidFill>
+              </a:rPr>
+              <a:t>What kind of confidence is needed?</a:t>
+            </a:r>
+            <a:endParaRPr lang="en-US" sz="2800" b="0" i="0" dirty="0">
+              <a:solidFill>
+                <a:srgbClr val="000000"/>
+              </a:solidFill>
+            </a:endParaRPr>
           </a:p>
         </p:txBody>
       </p:sp>
@@ -18059,8 +18054,8 @@
         </p:nvSpPr>
         <p:spPr>
           <a:xfrm>
-            <a:off x="685800" y="2700000"/>
-            <a:ext cx="7772400" cy="500000"/>
+            <a:off x="547374" y="4092529"/>
+            <a:ext cx="8181348" cy="500000"/>
           </a:xfrm>
           <a:prstGeom prst="rect">
             <a:avLst/>
@@ -18088,155 +18083,36 @@
           </a:p>
         </p:txBody>
       </p:sp>
-      <p:sp>
-        <p:nvSpPr>
-          <p:cNvPr id="102" name="TPSbadge"/>
-          <p:cNvSpPr/>
-          <p:nvPr/>
-        </p:nvSpPr>
-        <p:spPr>
-          <a:xfrm>
-            <a:off x="2972000" y="3560000"/>
-            <a:ext cx="3200000" cy="640000"/>
-          </a:xfrm>
-          <a:prstGeom prst="roundRect">
-            <a:avLst/>
-          </a:prstGeom>
-          <a:solidFill>
-            <a:srgbClr val="FBF8F2"/>
-          </a:solidFill>
-          <a:ln w="15875">
-            <a:solidFill>
-              <a:srgbClr val="8E6F3E"/>
-            </a:solidFill>
-          </a:ln>
-        </p:spPr>
-        <p:txBody>
-          <a:bodyPr wrap="square" lIns="91440" tIns="45720" rIns="91440" bIns="45720" anchor="ctr"/>
-          <a:lstStyle/>
-          <a:p>
-            <a:pPr algn="ctr">
-              <a:buNone/>
-            </a:pPr>
-            <a:r>
-              <a:rPr lang="en-US" sz="2200" b="1" i="0" dirty="0">
-                <a:solidFill>
-                  <a:srgbClr val="6B3FA0"/>
-                </a:solidFill>
-              </a:rPr>
-              <a:t>THINK</a:t>
-            </a:r>
-            <a:r>
-              <a:rPr lang="en-US" sz="2200" b="1" i="0" dirty="0">
-                <a:solidFill>
-                  <a:srgbClr val="9A9A9A"/>
-                </a:solidFill>
-              </a:rPr>
-              <a:t xml:space="preserve">  ·  </a:t>
-            </a:r>
-            <a:r>
-              <a:rPr lang="en-US" sz="2200" b="1" i="0" dirty="0">
-                <a:solidFill>
-                  <a:srgbClr val="2E74B5"/>
-                </a:solidFill>
-              </a:rPr>
-              <a:t>PAIR</a:t>
-            </a:r>
-            <a:r>
-              <a:rPr lang="en-US" sz="2200" b="1" i="0" dirty="0">
-                <a:solidFill>
-                  <a:srgbClr val="9A9A9A"/>
-                </a:solidFill>
-              </a:rPr>
-              <a:t xml:space="preserve">  ·  </a:t>
-            </a:r>
-            <a:r>
-              <a:rPr lang="en-US" sz="2200" b="1" i="0" dirty="0">
-                <a:solidFill>
-                  <a:srgbClr val="B8860B"/>
-                </a:solidFill>
-              </a:rPr>
-              <a:t>SHARE</a:t>
-            </a:r>
-          </a:p>
-        </p:txBody>
-      </p:sp>
-      <p:sp>
-        <p:nvSpPr>
-          <p:cNvPr id="103" name="T103"/>
-          <p:cNvSpPr txBox="1"/>
-          <p:nvPr/>
-        </p:nvSpPr>
-        <p:spPr>
-          <a:xfrm>
-            <a:off x="685800" y="4460000"/>
-            <a:ext cx="7772400" cy="600000"/>
-          </a:xfrm>
-          <a:prstGeom prst="rect">
-            <a:avLst/>
-          </a:prstGeom>
-          <a:noFill/>
-          <a:ln>
-            <a:noFill/>
-          </a:ln>
-        </p:spPr>
-        <p:txBody>
-          <a:bodyPr wrap="square" lIns="0" tIns="0" rIns="0" bIns="0" anchor="t"/>
-          <a:lstStyle/>
-          <a:p>
-            <a:pPr algn="ctr">
-              <a:buNone/>
-            </a:pPr>
-            <a:r>
-              <a:rPr lang="en-US" sz="1900" b="0" i="0" dirty="0">
-                <a:solidFill>
-                  <a:srgbClr val="5C4826"/>
-                </a:solidFill>
-              </a:rPr>
-              <a:t>Should they receive the same validation strategy? Why not?</a:t>
-            </a:r>
-          </a:p>
-        </p:txBody>
-      </p:sp>
-      <p:sp>
-        <p:nvSpPr>
-          <p:cNvPr id="113" name="FooterBand"/>
-          <p:cNvSpPr/>
-          <p:nvPr/>
-        </p:nvSpPr>
-        <p:spPr>
-          <a:xfrm>
-            <a:off x="274320" y="5852160"/>
-            <a:ext cx="8595360" cy="566928"/>
-          </a:xfrm>
-          <a:prstGeom prst="rect">
-            <a:avLst/>
-          </a:prstGeom>
-          <a:solidFill>
-            <a:srgbClr val="8E6F3E"/>
-          </a:solidFill>
-          <a:ln>
-            <a:noFill/>
-          </a:ln>
-        </p:spPr>
-        <p:txBody>
-          <a:bodyPr wrap="square" lIns="91440" tIns="45720" rIns="91440" bIns="45720" anchor="ctr"/>
-          <a:lstStyle/>
-          <a:p>
-            <a:pPr algn="ctr">
-              <a:buNone/>
-            </a:pPr>
-            <a:r>
-              <a:rPr lang="en-US" sz="2000" b="1" i="0" dirty="0">
-                <a:solidFill>
-                  <a:srgbClr val="FFFFFF"/>
-                </a:solidFill>
-              </a:rPr>
-              <a:t>Reach for the honest first answer. Then we make it precise.</a:t>
-            </a:r>
-          </a:p>
-        </p:txBody>
-      </p:sp>
+      <p:pic>
+        <p:nvPicPr>
+          <p:cNvPr id="4" name="Think Pair Share banner" descr="Think, Pair, Share">
+            <a:extLst>
+              <a:ext uri="{FF2B5EF4-FFF2-40B4-BE49-F238E27FC236}">
+                <a16:creationId xmlns:a16="http://schemas.microsoft.com/office/drawing/2014/main" id="{9ED59124-F5ED-9B82-55A8-6D593C16C538}"/>
+              </a:ext>
+            </a:extLst>
+          </p:cNvPr>
+          <p:cNvPicPr>
+            <a:picLocks noChangeAspect="1"/>
+          </p:cNvPicPr>
+          <p:nvPr/>
+        </p:nvPicPr>
+        <p:blipFill>
+          <a:blip r:embed="rId2"/>
+          <a:stretch>
+            <a:fillRect/>
+          </a:stretch>
+        </p:blipFill>
+        <p:spPr>
+          <a:xfrm>
+            <a:off x="2476500" y="1308972"/>
+            <a:ext cx="4191000" cy="1206500"/>
+          </a:xfrm>
+          <a:prstGeom prst="rect">
+            <a:avLst/>
+          </a:prstGeom>
+        </p:spPr>
+      </p:pic>
     </p:spTree>
   </p:cSld>
   <p:clrMapOvr>
@@ -18294,7 +18170,7 @@
                   <a:srgbClr val="000000"/>
                 </a:solidFill>
               </a:rPr>
-              <a:t>“It depends” is the beginning of the engineering answer, not the end</a:t>
+              <a:t>“It depends” is the beginning of the answer, not the end</a:t>
             </a:r>
           </a:p>
         </p:txBody>
@@ -18316,7 +18192,7 @@
           <a:p>
             <a:fld id="{B7EB45DA-9A0D-DC49-8E02-F30A5DDC21C3}" type="slidenum">
               <a:rPr lang="en-US" smtClean="0"/>
-              <a:t>1</a:t>
+              <a:t>5</a:t>
             </a:fld>
             <a:endParaRPr lang="en-US"/>
           </a:p>
@@ -18595,7 +18471,7 @@
                   <a:srgbClr val="000000"/>
                 </a:solidFill>
               </a:rPr>
-              <a:t>Radiation control</a:t>
+              <a:t>X-Ray control</a:t>
             </a:r>
           </a:p>
           <a:p>
@@ -18661,8 +18537,8 @@
         </p:nvSpPr>
         <p:spPr>
           <a:xfrm>
-            <a:off x="274320" y="5852160"/>
-            <a:ext cx="8595360" cy="566928"/>
+            <a:off x="274320" y="5519088"/>
+            <a:ext cx="8595360" cy="900000"/>
           </a:xfrm>
           <a:prstGeom prst="rect">
             <a:avLst/>
@@ -18682,12 +18558,49 @@
               <a:buNone/>
             </a:pPr>
             <a:r>
-              <a:rPr lang="en-US" sz="2000" b="1" i="0" dirty="0">
+              <a:rPr lang="en-US" sz="2400" i="0" dirty="0">
                 <a:solidFill>
                   <a:srgbClr val="FFFFFF"/>
                 </a:solidFill>
               </a:rPr>
-              <a:t>Our job: say what it depends on, and how that changes the evidence we require.</a:t>
+              <a:t>Engineers say what it depends </a:t>
+            </a:r>
+            <a:r>
+              <a:rPr lang="en-US" sz="2400" b="1" i="1" dirty="0">
+                <a:solidFill>
+                  <a:srgbClr val="FFFFFF"/>
+                </a:solidFill>
+              </a:rPr>
+              <a:t>on</a:t>
+            </a:r>
+            <a:r>
+              <a:rPr lang="en-US" sz="2400" b="1" i="0" dirty="0">
+                <a:solidFill>
+                  <a:srgbClr val="FFFFFF"/>
+                </a:solidFill>
+              </a:rPr>
+              <a:t>, </a:t>
+            </a:r>
+            <a:r>
+              <a:rPr lang="en-US" sz="2400" i="0" dirty="0">
+                <a:solidFill>
+                  <a:srgbClr val="FFFFFF"/>
+                </a:solidFill>
+              </a:rPr>
+              <a:t>and</a:t>
+            </a:r>
+          </a:p>
+          <a:p>
+            <a:pPr algn="ctr">
+              <a:buNone/>
+            </a:pPr>
+            <a:r>
+              <a:rPr lang="en-US" sz="2400" i="0" dirty="0">
+                <a:solidFill>
+                  <a:srgbClr val="FFFFFF"/>
+                </a:solidFill>
+              </a:rPr>
+              <a:t>how that changes the evidence we require.</a:t>
             </a:r>
           </a:p>
         </p:txBody>
@@ -18771,7 +18684,7 @@
           <a:p>
             <a:fld id="{B7EB45DA-9A0D-DC49-8E02-F30A5DDC21C3}" type="slidenum">
               <a:rPr lang="en-US" smtClean="0"/>
-              <a:t>1</a:t>
+              <a:t>6</a:t>
             </a:fld>
             <a:endParaRPr lang="en-US"/>
           </a:p>
@@ -19035,7 +18948,7 @@
                   <a:srgbClr val="FFFFFF"/>
                 </a:solidFill>
               </a:rPr>
-              <a:t>MEDICAL DEVICE</a:t>
+              <a:t>X-Ray Control</a:t>
             </a:r>
           </a:p>
         </p:txBody>
@@ -19284,7 +19197,7 @@
           <a:p>
             <a:fld id="{B7EB45DA-9A0D-DC49-8E02-F30A5DDC21C3}" type="slidenum">
               <a:rPr lang="en-US" smtClean="0"/>
-              <a:t>1</a:t>
+              <a:t>7</a:t>
             </a:fld>
             <a:endParaRPr lang="en-US"/>
           </a:p>
@@ -19559,7 +19472,7 @@
         </p:spPr>
         <p:txBody>
           <a:bodyPr>
-            <a:normAutofit fontScale="90000"/>
+            <a:normAutofit/>
           </a:bodyPr>
           <a:lstStyle/>
           <a:p>
@@ -19595,7 +19508,7 @@
           <a:p>
             <a:fld id="{B7EB45DA-9A0D-DC49-8E02-F30A5DDC21C3}" type="slidenum">
               <a:rPr lang="en-US" smtClean="0"/>
-              <a:t>1</a:t>
+              <a:t>8</a:t>
             </a:fld>
             <a:endParaRPr lang="en-US"/>
           </a:p>
@@ -19786,7 +19699,7 @@
           <a:p>
             <a:fld id="{B7EB45DA-9A0D-DC49-8E02-F30A5DDC21C3}" type="slidenum">
               <a:rPr lang="en-US" smtClean="0"/>
-              <a:t>1</a:t>
+              <a:t>9</a:t>
             </a:fld>
             <a:endParaRPr lang="en-US"/>
           </a:p>

</xml_diff>

<commit_message>
course(validation deck): §1-3 QA pass — fix at-most-one/exactly-one contradiction, quote the spec verbatim, unify the scope-row grids
</commit_message>
<xml_diff>
--- a/course/lectures/act-1-foundations/08-validation/1-8-Validation.pptx
+++ b/course/lectures/act-1-foundations/08-validation/1-8-Validation.pptx
@@ -6826,43 +6826,6 @@
       </p:sp>
       <p:sp>
         <p:nvSpPr>
-          <p:cNvPr id="116" name="T116"/>
-          <p:cNvSpPr txBox="1"/>
-          <p:nvPr/>
-        </p:nvSpPr>
-        <p:spPr>
-          <a:xfrm>
-            <a:off x="1780000" y="4090000"/>
-            <a:ext cx="1700000" cy="300000"/>
-          </a:xfrm>
-          <a:prstGeom prst="rect">
-            <a:avLst/>
-          </a:prstGeom>
-          <a:noFill/>
-          <a:ln>
-            <a:noFill/>
-          </a:ln>
-        </p:spPr>
-        <p:txBody>
-          <a:bodyPr wrap="square" lIns="0" tIns="0" rIns="0" bIns="0" anchor="t"/>
-          <a:lstStyle/>
-          <a:p>
-            <a:pPr algn="l">
-              <a:buNone/>
-            </a:pPr>
-            <a:r>
-              <a:rPr lang="en-US" sz="1050" b="0" i="1" dirty="0">
-                <a:solidFill>
-                  <a:srgbClr val="555960"/>
-                </a:solidFill>
-              </a:rPr>
-              <a:t>(no fixed number of levels)</a:t>
-            </a:r>
-          </a:p>
-        </p:txBody>
-      </p:sp>
-      <p:sp>
-        <p:nvSpPr>
           <p:cNvPr id="117" name="T117"/>
           <p:cNvSpPr txBox="1"/>
           <p:nvPr/>
@@ -6986,7 +6949,7 @@
                   <a:srgbClr val="57534E"/>
                 </a:solidFill>
               </a:rPr>
-              <a:t>READ IT AS A CHAIN OF MODELS</a:t>
+              <a:t>A CHAIN OF MODELS</a:t>
             </a:r>
           </a:p>
           <a:p>
@@ -7333,50 +7296,6 @@
                             </p:childTnLst>
                           </p:cTn>
                         </p:par>
-                        <p:par>
-                          <p:cTn id="31" fill="hold">
-                            <p:stCondLst>
-                              <p:cond delay="0"/>
-                            </p:stCondLst>
-                            <p:childTnLst>
-                              <p:par>
-                                <p:cTn id="32" presetID="10" presetClass="entr" presetSubtype="0" fill="hold" grpId="6" nodeType="withEffect">
-                                  <p:stCondLst>
-                                    <p:cond delay="0"/>
-                                  </p:stCondLst>
-                                  <p:childTnLst>
-                                    <p:set>
-                                      <p:cBhvr>
-                                        <p:cTn id="33" dur="1" fill="hold">
-                                          <p:stCondLst>
-                                            <p:cond delay="0"/>
-                                          </p:stCondLst>
-                                        </p:cTn>
-                                        <p:tgtEl>
-                                          <p:spTgt spid="116"/>
-                                        </p:tgtEl>
-                                        <p:attrNameLst>
-                                          <p:attrName>style.visibility</p:attrName>
-                                        </p:attrNameLst>
-                                      </p:cBhvr>
-                                      <p:to>
-                                        <p:strVal val="visible"/>
-                                      </p:to>
-                                    </p:set>
-                                    <p:animEffect transition="in" filter="fade">
-                                      <p:cBhvr>
-                                        <p:cTn id="34" dur="500"/>
-                                        <p:tgtEl>
-                                          <p:spTgt spid="116"/>
-                                        </p:tgtEl>
-                                      </p:cBhvr>
-                                    </p:animEffect>
-                                  </p:childTnLst>
-                                </p:cTn>
-                              </p:par>
-                            </p:childTnLst>
-                          </p:cTn>
-                        </p:par>
                       </p:childTnLst>
                     </p:cTn>
                   </p:par>
@@ -7408,7 +7327,6 @@
       <p:bldP spid="113" grpId="3" animBg="1"/>
       <p:bldP spid="114" grpId="4" animBg="1"/>
       <p:bldP spid="115" grpId="5" animBg="1"/>
-      <p:bldP spid="116" grpId="6"/>
     </p:bldLst>
   </p:timing>
 </p:sld>
@@ -7463,7 +7381,7 @@
                   <a:srgbClr val="000000"/>
                 </a:solidFill>
               </a:rPr>
-              <a:t>The V is the summary: models left, evidence at matching scopes right</a:t>
+              <a:t>The V: models left, evidence at matching scopes right</a:t>
             </a:r>
           </a:p>
         </p:txBody>
@@ -8060,7 +7978,7 @@
         </p:nvSpPr>
         <p:spPr>
           <a:xfrm>
-            <a:off x="6420000" y="3560000"/>
+            <a:off x="6420000" y="3438144"/>
             <a:ext cx="2300000" cy="560000"/>
           </a:xfrm>
           <a:prstGeom prst="rect">
@@ -8546,7 +8464,7 @@
                   <a:srgbClr val="000000"/>
                 </a:solidFill>
               </a:rPr>
-              <a:t>evidence that the system is acceptable for its intended use</a:t>
+              <a:t>evidence that the delivered system achieves its purpose in the world</a:t>
             </a:r>
           </a:p>
         </p:txBody>
@@ -8940,7 +8858,7 @@
                   <a:srgbClr val="000000"/>
                 </a:solidFill>
               </a:rPr>
-              <a:t>Check a property at the lowest scope that can establish it</a:t>
+              <a:t>How low can the evidence go?</a:t>
             </a:r>
           </a:p>
         </p:txBody>
@@ -9214,12 +9132,12 @@
               <a:buNone/>
             </a:pPr>
             <a:r>
-              <a:rPr lang="en-US" sz="1700" b="1" i="0" dirty="0">
+              <a:rPr lang="en-US" sz="2000" b="1" i="0" dirty="0">
                 <a:solidFill>
                   <a:srgbClr val="FFFFFF"/>
                 </a:solidFill>
               </a:rPr>
-              <a:t>The cheapest scope that can establish the property — never cheaper than the property itself.</a:t>
+              <a:t>As cheap as the property allows — and no cheaper.</a:t>
             </a:r>
           </a:p>
         </p:txBody>
@@ -18594,7 +18512,7 @@
                   <a:srgbClr val="000000"/>
                 </a:solidFill>
               </a:rPr>
-              <a:t>Assemble the service, submit a payment, and check that exactly one charge appears.</a:t>
+              <a:t>Assemble the service, submit a payment, and check that no more than one charge appears.</a:t>
             </a:r>
           </a:p>
         </p:txBody>
@@ -19261,7 +19179,7 @@
           </a:ln>
         </p:spPr>
         <p:txBody>
-          <a:bodyPr wrap="square" lIns="91440" tIns="45720" rIns="91440" bIns="45720" anchor="t"/>
+          <a:bodyPr wrap="square" lIns="91440" tIns="45720" rIns="91440" bIns="45720" anchor="ctr"/>
           <a:lstStyle/>
           <a:p>
             <a:pPr algn="ctr">
@@ -19318,7 +19236,7 @@
           </a:ln>
         </p:spPr>
         <p:txBody>
-          <a:bodyPr wrap="square" lIns="91440" tIns="45720" rIns="91440" bIns="45720" anchor="t"/>
+          <a:bodyPr wrap="square" lIns="91440" tIns="45720" rIns="91440" bIns="45720" anchor="ctr"/>
           <a:lstStyle/>
           <a:p>
             <a:pPr algn="ctr">
@@ -19375,7 +19293,7 @@
           </a:ln>
         </p:spPr>
         <p:txBody>
-          <a:bodyPr wrap="square" lIns="91440" tIns="45720" rIns="91440" bIns="45720" anchor="t"/>
+          <a:bodyPr wrap="square" lIns="91440" tIns="45720" rIns="91440" bIns="45720" anchor="ctr"/>
           <a:lstStyle/>
           <a:p>
             <a:pPr algn="ctr">
@@ -19444,7 +19362,7 @@
                   <a:srgbClr val="000000"/>
                 </a:solidFill>
               </a:rPr>
-              <a:t>And some properties are far cheaper to exercise at a smaller scope: rejecting a duplicate payment id needs one component, not a deployment.</a:t>
+              <a:t>Some properties are also far cheaper to exercise at a smaller scope: rejecting a duplicate payment ID needs one component, not a deployment.</a:t>
             </a:r>
           </a:p>
         </p:txBody>
@@ -19838,8 +19756,8 @@
         </p:nvSpPr>
         <p:spPr>
           <a:xfrm>
-            <a:off x="566928" y="896112"/>
-            <a:ext cx="8010144" cy="566928"/>
+            <a:off x="676656" y="896112"/>
+            <a:ext cx="7936992" cy="566928"/>
           </a:xfrm>
           <a:prstGeom prst="rect">
             <a:avLst/>
@@ -19866,7 +19784,7 @@
                   <a:srgbClr val="5C4826"/>
                 </a:solidFill>
               </a:rPr>
-              <a:t>SPECIFICATION:  a submitted payment shall cause at most one charge.</a:t>
+              <a:t>SPECIFICATION: a submitted payment shall cause at most one charge.</a:t>
             </a:r>
           </a:p>
         </p:txBody>
@@ -19879,8 +19797,8 @@
         </p:nvSpPr>
         <p:spPr>
           <a:xfrm>
-            <a:off x="566928" y="1645920"/>
-            <a:ext cx="2011680" cy="566928"/>
+            <a:off x="676656" y="1627632"/>
+            <a:ext cx="2395728" cy="640080"/>
           </a:xfrm>
           <a:prstGeom prst="rect">
             <a:avLst/>
@@ -19918,8 +19836,8 @@
         </p:nvSpPr>
         <p:spPr>
           <a:xfrm>
-            <a:off x="2743200" y="1645920"/>
-            <a:ext cx="5833872" cy="566928"/>
+            <a:off x="3163824" y="1627632"/>
+            <a:ext cx="5458968" cy="640080"/>
           </a:xfrm>
           <a:prstGeom prst="rect">
             <a:avLst/>
@@ -19946,7 +19864,7 @@
                   <a:srgbClr val="000000"/>
                 </a:solidFill>
               </a:rPr>
-              <a:t>Does the idempotency component reject a duplicate payment id?</a:t>
+              <a:t>Does the idempotency component reject a duplicate payment ID?</a:t>
             </a:r>
           </a:p>
         </p:txBody>
@@ -19959,8 +19877,8 @@
         </p:nvSpPr>
         <p:spPr>
           <a:xfrm>
-            <a:off x="566928" y="2313432"/>
-            <a:ext cx="2011680" cy="566928"/>
+            <a:off x="676656" y="2340864"/>
+            <a:ext cx="2395728" cy="640080"/>
           </a:xfrm>
           <a:prstGeom prst="rect">
             <a:avLst/>
@@ -19998,8 +19916,8 @@
         </p:nvSpPr>
         <p:spPr>
           <a:xfrm>
-            <a:off x="2743200" y="2313432"/>
-            <a:ext cx="5833872" cy="566928"/>
+            <a:off x="3163824" y="2340864"/>
+            <a:ext cx="5458968" cy="640080"/>
           </a:xfrm>
           <a:prstGeom prst="rect">
             <a:avLst/>
@@ -20039,8 +19957,8 @@
         </p:nvSpPr>
         <p:spPr>
           <a:xfrm>
-            <a:off x="566928" y="2980944"/>
-            <a:ext cx="2011680" cy="566928"/>
+            <a:off x="676656" y="3054096"/>
+            <a:ext cx="2395728" cy="640080"/>
           </a:xfrm>
           <a:prstGeom prst="rect">
             <a:avLst/>
@@ -20078,8 +19996,8 @@
         </p:nvSpPr>
         <p:spPr>
           <a:xfrm>
-            <a:off x="2743200" y="2980944"/>
-            <a:ext cx="5833872" cy="566928"/>
+            <a:off x="3163824" y="3054096"/>
+            <a:ext cx="5458968" cy="640080"/>
           </a:xfrm>
           <a:prstGeom prst="rect">
             <a:avLst/>
@@ -20106,7 +20024,7 @@
                   <a:srgbClr val="000000"/>
                 </a:solidFill>
               </a:rPr>
-              <a:t>Can one submitted payment ever produce two charges at the service boundary?</a:t>
+              <a:t>Can one submitted payment ever produce two charges at the boundary?</a:t>
             </a:r>
           </a:p>
         </p:txBody>
@@ -20119,8 +20037,8 @@
         </p:nvSpPr>
         <p:spPr>
           <a:xfrm>
-            <a:off x="566928" y="3648456"/>
-            <a:ext cx="2011680" cy="566928"/>
+            <a:off x="676656" y="3767328"/>
+            <a:ext cx="2395728" cy="640080"/>
           </a:xfrm>
           <a:prstGeom prst="rect">
             <a:avLst/>
@@ -20158,8 +20076,8 @@
         </p:nvSpPr>
         <p:spPr>
           <a:xfrm>
-            <a:off x="2743200" y="3648456"/>
-            <a:ext cx="5833872" cy="566928"/>
+            <a:off x="3163824" y="3767328"/>
+            <a:ext cx="5458968" cy="640080"/>
           </a:xfrm>
           <a:prstGeom prst="rect">
             <a:avLst/>
@@ -20199,8 +20117,8 @@
         </p:nvSpPr>
         <p:spPr>
           <a:xfrm>
-            <a:off x="566928" y="4434840"/>
-            <a:ext cx="8010144" cy="914400"/>
+            <a:off x="676656" y="4572000"/>
+            <a:ext cx="7936992" cy="914400"/>
           </a:xfrm>
           <a:prstGeom prst="rect">
             <a:avLst/>
@@ -22516,7 +22434,7 @@
                   <a:srgbClr val="5C4826"/>
                 </a:solidFill>
               </a:rPr>
-              <a:t>RULE: record the payment id BEFORE charging it — a retry must never charge twice.</a:t>
+              <a:t>RULE: record the payment ID BEFORE charging it — a retry must never charge twice.</a:t>
             </a:r>
           </a:p>
         </p:txBody>
@@ -23094,7 +23012,7 @@
                   <a:srgbClr val="5C4826"/>
                 </a:solidFill>
               </a:rPr>
-              <a:t>RULE: record the payment id BEFORE charging it — a retry must never charge twice.</a:t>
+              <a:t>RULE: record the payment ID BEFORE charging it — a retry must never charge twice.</a:t>
             </a:r>
           </a:p>
         </p:txBody>
@@ -26766,7 +26684,7 @@
                   <a:srgbClr val="000000"/>
                 </a:solidFill>
               </a:rPr>
-              <a:t>Software is updateable.</a:t>
+              <a:t>Software is updatable.</a:t>
             </a:r>
           </a:p>
           <a:p>
@@ -27248,7 +27166,7 @@
                   <a:srgbClr val="000000"/>
                 </a:solidFill>
               </a:rPr>
-              <a:t>A payment submitted once is charged at most once</a:t>
+              <a:t>A submitted payment shall cause at most one charge</a:t>
             </a:r>
           </a:p>
         </p:txBody>

</xml_diff>